<commit_message>
docs(deck): re-label slide 18 as v1.1 preview, point at ask.py
Conditional `when:` edges on `workflow.yaml` aren't shipped yet (v0.3
IR is sequential-only; conditional + langgraph compiler lands in v1.1).
Slide 18 still describes the shape of that v1.1 syntax but no longer
implies it runs today.

Changes to slide 18 only:
- Title gains `[v1.1 preview]` tag so it's clear at a glance
- Subtitle: "Coming in v1.1: declarative conditional routing. Today:
  orchestrate in a 5-line Python or bash script."
- Code-block comment marks it `← v1.1 syntax`
- Explanation bullets use future tense ("will unlock", "will support")
- New footer points to `ask.py` in the demo repo as the today-it-works
  alternative

Everything else in the deck stays as-is — Part 1 (build agents),
Part 3 (eval + bench), Part 4 (deploy), Part 5 (recap) all run on
current code.

Co-Authored-By: Claude Opus 4.7 (1M context) <noreply@anthropic.com>
</commit_message>
<xml_diff>
--- a/docs/movate-cli-demo-deck.pptx
+++ b/docs/movate-cli-demo-deck.pptx
@@ -7030,7 +7030,7 @@
               </a:defRPr>
             </a:pPr>
             <a:r>
-              <a:t>Step 5 — The workflow.yaml</a:t>
+              <a:t>Step 5 — The workflow.yaml   [v1.1 preview]</a:t>
             </a:r>
           </a:p>
         </p:txBody>
@@ -7065,7 +7065,7 @@
               </a:defRPr>
             </a:pPr>
             <a:r>
-              <a:t>One file describes the entire routing topology</a:t>
+              <a:t>Coming in v1.1: declarative conditional routing. Today: orchestrate in a 5-line Python or bash script.</a:t>
             </a:r>
           </a:p>
         </p:txBody>
@@ -7148,7 +7148,7 @@
               </a:defRPr>
             </a:pPr>
             <a:r>
-              <a:t># movate-faq/workflow.yaml</a:t>
+              <a:t># movate-faq/workflow.yaml      ← v1.1 syntax</a:t>
             </a:r>
           </a:p>
           <a:p>
@@ -7670,7 +7670,7 @@
               </a:defRPr>
             </a:pPr>
             <a:r>
-              <a:t>**`runtime: langgraph`** unlocks conditional edges. The default homegrown runner only handles linear DAGs.</a:t>
+              <a:t>**`runtime: langgraph`** will unlock conditional edges. The default homegrown runner today only handles linear DAGs — conditional support lands in v1.1.</a:t>
             </a:r>
           </a:p>
           <a:p>
@@ -7685,7 +7685,7 @@
               </a:defRPr>
             </a:pPr>
             <a:r>
-              <a:t>**JSONPath-like DSL** in the `when:` clauses — supports `==`, `!=`, `&lt;`, `&gt;`, `&amp;&amp;`, `||`, `in [...]`. No `eval()`, no third-party dep.</a:t>
+              <a:t>**JSONPath-like DSL** in the `when:` clauses — will support `==`, `!=`, `&lt;`, `&gt;`, `&amp;&amp;`, `||`, `in [...]`. No `eval()`, no third-party dep.</a:t>
             </a:r>
           </a:p>
           <a:p>
@@ -7700,7 +7700,42 @@
               </a:defRPr>
             </a:pPr>
             <a:r>
-              <a:t>**Default branch (`when: null`) is required and must be last** — covers the "manager misclassified" or "unknown intent" case. We route to cli_expert as a safe fallback.</a:t>
+              <a:t>**Default branch (`when: null`)** — covers the "manager misclassified" or "unknown intent" case. Required + must be last in the edge list.</a:t>
+            </a:r>
+          </a:p>
+        </p:txBody>
+      </p:sp>
+      <p:sp>
+        <p:nvSpPr>
+          <p:cNvPr id="8" name="TextBox 7"/>
+          <p:cNvSpPr txBox="1"/>
+          <p:nvPr/>
+        </p:nvSpPr>
+        <p:spPr>
+          <a:xfrm>
+            <a:off x="548640" y="6355080"/>
+            <a:ext cx="11091672" cy="365760"/>
+          </a:xfrm>
+          <a:prstGeom prst="rect">
+            <a:avLst/>
+          </a:prstGeom>
+          <a:noFill/>
+        </p:spPr>
+        <p:txBody>
+          <a:bodyPr wrap="square">
+            <a:spAutoFit/>
+          </a:bodyPr>
+          <a:lstStyle/>
+          <a:p>
+            <a:pPr>
+              <a:defRPr sz="1100" b="0" i="0">
+                <a:solidFill>
+                  <a:srgbClr val="555555"/>
+                </a:solidFill>
+              </a:defRPr>
+            </a:pPr>
+            <a:r>
+              <a:t>v1.1 preview — until then, route in client code. See the movate-faq-demo repo's ask.py for the 40-line orchestration pattern that runs today.</a:t>
             </a:r>
           </a:p>
         </p:txBody>

</xml_diff>